<commit_message>
Refine today's journey: two security lanes and self check-in kiosks
Security now has one queue splitting into two staffed lanes (tray
loading, X-ray, walk-through detector, reclaim) plus bag search; check-in
adds a bank of three self-service kiosks with a helper. Chip staff counts
are read from the scene (check-in 5, immigration 4, security 8, gate 3).

Co-Authored-By: Claude Opus 5.5 <noreply@anthropic.com>
Claude-Session: https://claude.ai/code/session_017QB5LGF7rtAPE1GUPfCLTP
</commit_message>
<xml_diff>
--- a/FastPass_Deck/FastPass_Slide2_Today_Journey.pptx
+++ b/FastPass_Deck/FastPass_Slide2_Today_Journey.pptx
@@ -4579,7 +4579,7 @@
         </p:nvSpPr>
         <p:spPr>
           <a:xfrm>
-            <a:off x="2311512" y="3789411"/>
+            <a:off x="2242886" y="3755532"/>
             <a:ext cx="0" cy="192024"/>
           </a:xfrm>
           <a:prstGeom prst="line">
@@ -4602,7 +4602,7 @@
         </p:nvSpPr>
         <p:spPr>
           <a:xfrm>
-            <a:off x="2165208" y="3505947"/>
+            <a:off x="2096582" y="3472068"/>
             <a:ext cx="292608" cy="292608"/>
           </a:xfrm>
           <a:prstGeom prst="ellipse">
@@ -4634,7 +4634,7 @@
         </p:nvSpPr>
         <p:spPr>
           <a:xfrm>
-            <a:off x="2165208" y="3505947"/>
+            <a:off x="2096582" y="3472068"/>
             <a:ext cx="292608" cy="292608"/>
           </a:xfrm>
           <a:prstGeom prst="rect">
@@ -4761,7 +4761,7 @@
         </p:nvSpPr>
         <p:spPr>
           <a:xfrm>
-            <a:off x="7770297" y="3647816"/>
+            <a:off x="6555014" y="3039740"/>
             <a:ext cx="0" cy="192024"/>
           </a:xfrm>
           <a:prstGeom prst="line">
@@ -4784,7 +4784,7 @@
         </p:nvSpPr>
         <p:spPr>
           <a:xfrm>
-            <a:off x="7623993" y="3364352"/>
+            <a:off x="6408710" y="2756276"/>
             <a:ext cx="292608" cy="292608"/>
           </a:xfrm>
           <a:prstGeom prst="ellipse">
@@ -4816,7 +4816,7 @@
         </p:nvSpPr>
         <p:spPr>
           <a:xfrm>
-            <a:off x="7623993" y="3364352"/>
+            <a:off x="6408710" y="2756276"/>
             <a:ext cx="292608" cy="292608"/>
           </a:xfrm>
           <a:prstGeom prst="rect">
@@ -4944,7 +4944,7 @@
         <p:spPr>
           <a:xfrm>
             <a:off x="548640" y="1828800"/>
-            <a:ext cx="1691640" cy="786384"/>
+            <a:ext cx="1850362" cy="786384"/>
           </a:xfrm>
           <a:prstGeom prst="roundRect">
             <a:avLst>
@@ -5034,7 +5034,7 @@
         <p:spPr>
           <a:xfrm>
             <a:off x="987552" y="1874520"/>
-            <a:ext cx="1252728" cy="310896"/>
+            <a:ext cx="1411450" cy="310896"/>
           </a:xfrm>
           <a:prstGeom prst="rect">
             <a:avLst/>
@@ -5070,7 +5070,7 @@
         <p:spPr>
           <a:xfrm>
             <a:off x="658368" y="2176272"/>
-            <a:ext cx="1581912" cy="201168"/>
+            <a:ext cx="1740634" cy="201168"/>
           </a:xfrm>
           <a:prstGeom prst="rect">
             <a:avLst/>
@@ -5091,7 +5091,7 @@
                   <a:srgbClr val="4A5870"/>
                 </a:solidFill>
               </a:rPr>
-              <a:t>ID, ticket and bag drop</a:t>
+              <a:t>Kiosks and staffed counters</a:t>
             </a:r>
             <a:endParaRPr lang="en-US" sz="1000" dirty="0"/>
           </a:p>
@@ -5151,7 +5151,7 @@
                   <a:srgbClr val="0B2545"/>
                 </a:solidFill>
               </a:rPr>
-              <a:t>4 staff</a:t>
+              <a:t>5 staff</a:t>
             </a:r>
             <a:endParaRPr lang="en-US" sz="1000" dirty="0"/>
           </a:p>
@@ -5225,7 +5225,7 @@
         </p:nvSpPr>
         <p:spPr>
           <a:xfrm>
-            <a:off x="2423160" y="1828800"/>
+            <a:off x="2581882" y="1828800"/>
             <a:ext cx="1691640" cy="786384"/>
           </a:xfrm>
           <a:prstGeom prst="roundRect">
@@ -5259,7 +5259,7 @@
         </p:nvSpPr>
         <p:spPr>
           <a:xfrm>
-            <a:off x="2532888" y="1911096"/>
+            <a:off x="2691610" y="1911096"/>
             <a:ext cx="237744" cy="237744"/>
           </a:xfrm>
           <a:prstGeom prst="ellipse">
@@ -5279,7 +5279,7 @@
         </p:nvSpPr>
         <p:spPr>
           <a:xfrm>
-            <a:off x="2532888" y="1911096"/>
+            <a:off x="2691610" y="1911096"/>
             <a:ext cx="237744" cy="237744"/>
           </a:xfrm>
           <a:prstGeom prst="rect">
@@ -5315,7 +5315,7 @@
         </p:nvSpPr>
         <p:spPr>
           <a:xfrm>
-            <a:off x="2862072" y="1874520"/>
+            <a:off x="3020794" y="1874520"/>
             <a:ext cx="1252728" cy="310896"/>
           </a:xfrm>
           <a:prstGeom prst="rect">
@@ -5351,7 +5351,7 @@
         </p:nvSpPr>
         <p:spPr>
           <a:xfrm>
-            <a:off x="2532888" y="2176272"/>
+            <a:off x="2691610" y="2176272"/>
             <a:ext cx="1581912" cy="201168"/>
           </a:xfrm>
           <a:prstGeom prst="rect">
@@ -5395,7 +5395,7 @@
         </p:blipFill>
         <p:spPr>
           <a:xfrm>
-            <a:off x="2532888" y="2395728"/>
+            <a:off x="2691610" y="2395728"/>
             <a:ext cx="155448" cy="155448"/>
           </a:xfrm>
           <a:prstGeom prst="rect">
@@ -5411,7 +5411,7 @@
         </p:nvSpPr>
         <p:spPr>
           <a:xfrm>
-            <a:off x="2734056" y="2377440"/>
+            <a:off x="2892778" y="2377440"/>
             <a:ext cx="419735" cy="192024"/>
           </a:xfrm>
           <a:prstGeom prst="rect">
@@ -5455,7 +5455,7 @@
         </p:blipFill>
         <p:spPr>
           <a:xfrm>
-            <a:off x="3272663" y="2395728"/>
+            <a:off x="3431385" y="2395728"/>
             <a:ext cx="155448" cy="155448"/>
           </a:xfrm>
           <a:prstGeom prst="rect">
@@ -5471,7 +5471,7 @@
         </p:nvSpPr>
         <p:spPr>
           <a:xfrm>
-            <a:off x="3473831" y="2377440"/>
+            <a:off x="3632553" y="2377440"/>
             <a:ext cx="548640" cy="192024"/>
           </a:xfrm>
           <a:prstGeom prst="rect">
@@ -5655,7 +5655,7 @@
                   <a:srgbClr val="4A5870"/>
                 </a:solidFill>
               </a:rPr>
-              <a:t>Boarding pass and bags</a:t>
+              <a:t>Two lanes: bags and body scan</a:t>
             </a:r>
             <a:endParaRPr lang="en-US" sz="1000" dirty="0"/>
           </a:p>
@@ -5715,7 +5715,7 @@
                   <a:srgbClr val="0B2545"/>
                 </a:solidFill>
               </a:rPr>
-              <a:t>5 staff</a:t>
+              <a:t>8 staff</a:t>
             </a:r>
             <a:endParaRPr lang="en-US" sz="1000" dirty="0"/>
           </a:p>

</xml_diff>